<commit_message>
Fix rc3 training compatibility and presentation integrity
Restore binary-safe presentation artifacts and validate every archive member. Align the training stack with Transformers 5, preserve float32 settings, and share explicit legacy-weight handling across experiment loaders. Add real local training and mixed-format regression tests and document the verified prerelease workflow.
</commit_message>
<xml_diff>
--- a/docs/ERA_overview_presentation.pptx
+++ b/docs/ERA_overview_presentation.pptx
@@ -1,3 +1,405 @@
+
+<file path=ppt/presentation.xml><?xml version="1.0" encoding="utf-8"?>
+<p:presentation xmlns:a="http://schemas.openxmlformats.org/drawingml/2006/main" xmlns:p="http://schemas.openxmlformats.org/presentationml/2006/main" xmlns:r="http://schemas.openxmlformats.org/officeDocument/2006/relationships" xmlns:p14="http://schemas.microsoft.com/office/powerpoint/2010/main" xmlns:p15="http://schemas.microsoft.com/office/powerpoint/2012/main" xmlns:mc="http://schemas.openxmlformats.org/markup-compatibility/2006">
+  <p:sldMasterIdLst>
+    <p:sldMasterId id="2147483648" r:id="rId2"/>
+  </p:sldMasterIdLst>
+  <p:notesMasterIdLst>
+    <p:notesMasterId r:id="rId3"/>
+  </p:notesMasterIdLst>
+  <p:sldIdLst>
+    <p:sldId id="256" r:id="rId4"/>
+    <p:sldId id="257" r:id="rId5"/>
+    <p:sldId id="258" r:id="rId6"/>
+    <p:sldId id="259" r:id="rId7"/>
+    <p:sldId id="260" r:id="rId8"/>
+    <p:sldId id="261" r:id="rId9"/>
+    <p:sldId id="262" r:id="rId10"/>
+    <p:sldId id="263" r:id="rId11"/>
+    <p:sldId id="264" r:id="rId12"/>
+  </p:sldIdLst>
+  <p:sldSz cx="12192000" cy="6858000"/>
+  <p:notesSz cx="6858000" cy="9144000"/>
+</p:presentation>
+</file>
+
+<file path=ppt/notesMasters/notesMaster1.xml><?xml version="1.0" encoding="utf-8"?>
+<p:notesMaster xmlns:a="http://schemas.openxmlformats.org/drawingml/2006/main" xmlns:p="http://schemas.openxmlformats.org/presentationml/2006/main" xmlns:r="http://schemas.openxmlformats.org/officeDocument/2006/relationships" xmlns:p14="http://schemas.microsoft.com/office/powerpoint/2010/main" xmlns:p15="http://schemas.microsoft.com/office/powerpoint/2012/main" xmlns:mc="http://schemas.openxmlformats.org/markup-compatibility/2006">
+  <p:cSld>
+    <p:spTree>
+      <p:nvGrpSpPr>
+        <p:cNvPr id="1" name=""/>
+        <p:cNvGrpSpPr/>
+        <p:nvPr/>
+      </p:nvGrpSpPr>
+      <p:grpSpPr>
+        <a:xfrm>
+          <a:off x="0" y="0"/>
+          <a:ext cx="0" cy="0"/>
+          <a:chOff x="0" y="0"/>
+          <a:chExt cx="0" cy="0"/>
+        </a:xfrm>
+      </p:grpSpPr>
+      <p:sp>
+        <p:nvSpPr>
+          <p:cNvPr id="4" name="PlaceHolder 1"/>
+          <p:cNvSpPr>
+            <a:spLocks noGrp="1"/>
+          </p:cNvSpPr>
+          <p:nvPr>
+            <p:ph type="sldImg"/>
+          </p:nvPr>
+        </p:nvSpPr>
+        <p:spPr>
+          <a:xfrm>
+            <a:off x="216000" y="812520"/>
+            <a:ext cx="7127280" cy="4008960"/>
+          </a:xfrm>
+          <a:prstGeom prst="rect">
+            <a:avLst/>
+          </a:prstGeom>
+          <a:noFill/>
+          <a:ln w="0">
+            <a:noFill/>
+          </a:ln>
+        </p:spPr>
+        <p:txBody>
+          <a:bodyPr lIns="0" tIns="0" rIns="0" bIns="0" anchor="ctr">
+            <a:noAutofit/>
+          </a:bodyPr>
+          <a:p>
+            <a:pPr algn="ctr"/>
+            <a:r>
+              <a:rPr lang="it-IT" sz="4400" b="0" u="none" strike="noStrike">
+                <a:solidFill>
+                  <a:schemeClr val="dk1"/>
+                </a:solidFill>
+                <a:effectLst/>
+                <a:uFillTx/>
+                <a:latin typeface="Calibri Light"/>
+              </a:rPr>
+              <a:t>Fai clic per spostare la diapositiva</a:t>
+            </a:r>
+            <a:endParaRPr lang="it-IT" sz="4400" b="0" u="none" strike="noStrike">
+              <a:solidFill>
+                <a:schemeClr val="dk1"/>
+              </a:solidFill>
+              <a:effectLst/>
+              <a:uFillTx/>
+              <a:latin typeface="Calibri Light"/>
+            </a:endParaRPr>
+          </a:p>
+        </p:txBody>
+      </p:sp>
+      <p:sp>
+        <p:nvSpPr>
+          <p:cNvPr id="5" name="PlaceHolder 2"/>
+          <p:cNvSpPr>
+            <a:spLocks noGrp="1"/>
+          </p:cNvSpPr>
+          <p:nvPr>
+            <p:ph type="body"/>
+          </p:nvPr>
+        </p:nvSpPr>
+        <p:spPr>
+          <a:xfrm>
+            <a:off x="756000" y="5078520"/>
+            <a:ext cx="6047640" cy="4811040"/>
+          </a:xfrm>
+          <a:prstGeom prst="rect">
+            <a:avLst/>
+          </a:prstGeom>
+          <a:noFill/>
+          <a:ln w="0">
+            <a:noFill/>
+          </a:ln>
+        </p:spPr>
+        <p:txBody>
+          <a:bodyPr lIns="0" tIns="0" rIns="0" bIns="0" anchor="t">
+            <a:noAutofit/>
+          </a:bodyPr>
+          <a:p>
+            <a:pPr indent="0" algn="l">
+              <a:buNone/>
+            </a:pPr>
+            <a:r>
+              <a:rPr lang="it-IT" sz="2000" b="0" u="none" strike="noStrike">
+                <a:solidFill>
+                  <a:srgbClr val="000000"/>
+                </a:solidFill>
+                <a:effectLst/>
+                <a:uFillTx/>
+                <a:latin typeface="Arial"/>
+              </a:rPr>
+              <a:t>Fai clic per modificare il formato delle note</a:t>
+            </a:r>
+            <a:endParaRPr lang="it-IT" sz="2000" b="0" u="none" strike="noStrike">
+              <a:solidFill>
+                <a:srgbClr val="000000"/>
+              </a:solidFill>
+              <a:effectLst/>
+              <a:uFillTx/>
+              <a:latin typeface="Arial"/>
+            </a:endParaRPr>
+          </a:p>
+        </p:txBody>
+      </p:sp>
+      <p:sp>
+        <p:nvSpPr>
+          <p:cNvPr id="6" name="PlaceHolder 3"/>
+          <p:cNvSpPr>
+            <a:spLocks noGrp="1"/>
+          </p:cNvSpPr>
+          <p:nvPr>
+            <p:ph type="hdr"/>
+          </p:nvPr>
+        </p:nvSpPr>
+        <p:spPr>
+          <a:xfrm>
+            <a:off x="0" y="0"/>
+            <a:ext cx="3280680" cy="534240"/>
+          </a:xfrm>
+          <a:prstGeom prst="rect">
+            <a:avLst/>
+          </a:prstGeom>
+          <a:noFill/>
+          <a:ln w="0">
+            <a:noFill/>
+          </a:ln>
+        </p:spPr>
+        <p:txBody>
+          <a:bodyPr lIns="0" tIns="0" rIns="0" bIns="0" anchor="t">
+            <a:noAutofit/>
+          </a:bodyPr>
+          <a:p>
+            <a:pPr indent="0" algn="l">
+              <a:buNone/>
+            </a:pPr>
+            <a:r>
+              <a:rPr lang="it-IT" sz="1400" b="0" u="none" strike="noStrike">
+                <a:solidFill>
+                  <a:srgbClr val="000000"/>
+                </a:solidFill>
+                <a:effectLst/>
+                <a:uFillTx/>
+                <a:latin typeface="Times New Roman"/>
+              </a:rPr>
+              <a:t> </a:t>
+            </a:r>
+            <a:endParaRPr lang="it-IT" sz="1400" b="0" u="none" strike="noStrike">
+              <a:solidFill>
+                <a:srgbClr val="000000"/>
+              </a:solidFill>
+              <a:effectLst/>
+              <a:uFillTx/>
+              <a:latin typeface="Times New Roman"/>
+            </a:endParaRPr>
+          </a:p>
+        </p:txBody>
+      </p:sp>
+      <p:sp>
+        <p:nvSpPr>
+          <p:cNvPr id="7" name="PlaceHolder 4"/>
+          <p:cNvSpPr>
+            <a:spLocks noGrp="1"/>
+          </p:cNvSpPr>
+          <p:nvPr>
+            <p:ph type="dt" idx="1"/>
+          </p:nvPr>
+        </p:nvSpPr>
+        <p:spPr>
+          <a:xfrm>
+            <a:off x="4278960" y="0"/>
+            <a:ext cx="3280680" cy="534240"/>
+          </a:xfrm>
+          <a:prstGeom prst="rect">
+            <a:avLst/>
+          </a:prstGeom>
+          <a:noFill/>
+          <a:ln w="0">
+            <a:noFill/>
+          </a:ln>
+        </p:spPr>
+        <p:txBody>
+          <a:bodyPr lIns="0" tIns="0" rIns="0" bIns="0" anchor="t">
+            <a:noAutofit/>
+          </a:bodyPr>
+          <a:lstStyle>
+            <a:lvl1pPr indent="0" algn="r">
+              <a:buNone/>
+              <a:defRPr lang="it-IT" sz="1400" b="0" u="none" strike="noStrike">
+                <a:solidFill>
+                  <a:srgbClr val="000000"/>
+                </a:solidFill>
+                <a:effectLst/>
+                <a:uFillTx/>
+                <a:latin typeface="Times New Roman"/>
+              </a:defRPr>
+            </a:lvl1pPr>
+          </a:lstStyle>
+          <a:p>
+            <a:pPr indent="0" algn="r">
+              <a:buNone/>
+            </a:pPr>
+            <a:r>
+              <a:rPr lang="it-IT" sz="1400" b="0" u="none" strike="noStrike">
+                <a:solidFill>
+                  <a:srgbClr val="000000"/>
+                </a:solidFill>
+                <a:effectLst/>
+                <a:uFillTx/>
+                <a:latin typeface="Times New Roman"/>
+              </a:rPr>
+              <a:t> </a:t>
+            </a:r>
+            <a:endParaRPr lang="it-IT" sz="1400" b="0" u="none" strike="noStrike">
+              <a:solidFill>
+                <a:srgbClr val="000000"/>
+              </a:solidFill>
+              <a:effectLst/>
+              <a:uFillTx/>
+              <a:latin typeface="Times New Roman"/>
+            </a:endParaRPr>
+          </a:p>
+        </p:txBody>
+      </p:sp>
+      <p:sp>
+        <p:nvSpPr>
+          <p:cNvPr id="8" name="PlaceHolder 5"/>
+          <p:cNvSpPr>
+            <a:spLocks noGrp="1"/>
+          </p:cNvSpPr>
+          <p:nvPr>
+            <p:ph type="ftr" idx="2"/>
+          </p:nvPr>
+        </p:nvSpPr>
+        <p:spPr>
+          <a:xfrm>
+            <a:off x="0" y="10157400"/>
+            <a:ext cx="3280680" cy="534240"/>
+          </a:xfrm>
+          <a:prstGeom prst="rect">
+            <a:avLst/>
+          </a:prstGeom>
+          <a:noFill/>
+          <a:ln w="0">
+            <a:noFill/>
+          </a:ln>
+        </p:spPr>
+        <p:txBody>
+          <a:bodyPr lIns="0" tIns="0" rIns="0" bIns="0" anchor="b">
+            <a:noAutofit/>
+          </a:bodyPr>
+          <a:lstStyle>
+            <a:lvl1pPr indent="0" algn="l">
+              <a:buNone/>
+              <a:defRPr lang="it-IT" sz="1400" b="0" u="none" strike="noStrike">
+                <a:solidFill>
+                  <a:srgbClr val="000000"/>
+                </a:solidFill>
+                <a:effectLst/>
+                <a:uFillTx/>
+                <a:latin typeface="Times New Roman"/>
+              </a:defRPr>
+            </a:lvl1pPr>
+          </a:lstStyle>
+          <a:p>
+            <a:pPr indent="0" algn="l">
+              <a:buNone/>
+            </a:pPr>
+            <a:r>
+              <a:rPr lang="it-IT" sz="1400" b="0" u="none" strike="noStrike">
+                <a:solidFill>
+                  <a:srgbClr val="000000"/>
+                </a:solidFill>
+                <a:effectLst/>
+                <a:uFillTx/>
+                <a:latin typeface="Times New Roman"/>
+              </a:rPr>
+              <a:t> </a:t>
+            </a:r>
+            <a:endParaRPr lang="it-IT" sz="1400" b="0" u="none" strike="noStrike">
+              <a:solidFill>
+                <a:srgbClr val="000000"/>
+              </a:solidFill>
+              <a:effectLst/>
+              <a:uFillTx/>
+              <a:latin typeface="Times New Roman"/>
+            </a:endParaRPr>
+          </a:p>
+        </p:txBody>
+      </p:sp>
+      <p:sp>
+        <p:nvSpPr>
+          <p:cNvPr id="9" name="PlaceHolder 6"/>
+          <p:cNvSpPr>
+            <a:spLocks noGrp="1"/>
+          </p:cNvSpPr>
+          <p:nvPr>
+            <p:ph type="sldNum" idx="3"/>
+          </p:nvPr>
+        </p:nvSpPr>
+        <p:spPr>
+          <a:xfrm>
+            <a:off x="4278960" y="10157400"/>
+            <a:ext cx="3280680" cy="534240"/>
+          </a:xfrm>
+          <a:prstGeom prst="rect">
+            <a:avLst/>
+          </a:prstGeom>
+          <a:noFill/>
+          <a:ln w="0">
+            <a:noFill/>
+          </a:ln>
+        </p:spPr>
+        <p:txBody>
+          <a:bodyPr lIns="0" tIns="0" rIns="0" bIns="0" anchor="b">
+            <a:noAutofit/>
+          </a:bodyPr>
+          <a:lstStyle>
+            <a:lvl1pPr indent="0" algn="r">
+              <a:buNone/>
+              <a:defRPr lang="it-IT" sz="1400" b="0" u="none" strike="noStrike">
+                <a:solidFill>
+                  <a:srgbClr val="000000"/>
+                </a:solidFill>
+                <a:effectLst/>
+                <a:uFillTx/>
+                <a:latin typeface="Times New Roman"/>
+              </a:defRPr>
+            </a:lvl1pPr>
+          </a:lstStyle>
+          <a:p>
+            <a:pPr indent="0" algn="r">
+              <a:buNone/>
+            </a:pPr>
+            <a:fld id="{0D5890F3-D33A-4BF9-9D26-C84BE1B5174A}" type="slidenum">
+              <a:rPr lang="it-IT" sz="1400" b="0" u="none" strike="noStrike">
+                <a:solidFill>
+                  <a:srgbClr val="000000"/>
+                </a:solidFill>
+                <a:effectLst/>
+                <a:uFillTx/>
+                <a:latin typeface="Times New Roman"/>
+              </a:rPr>
+              <a:t>1</a:t>
+            </a:fld>
+            <a:endParaRPr lang="it-IT" sz="1400" b="0" u="none" strike="noStrike">
+              <a:solidFill>
+                <a:srgbClr val="000000"/>
+              </a:solidFill>
+              <a:effectLst/>
+              <a:uFillTx/>
+              <a:latin typeface="Times New Roman"/>
+            </a:endParaRPr>
+          </a:p>
+        </p:txBody>
+      </p:sp>
+    </p:spTree>
+  </p:cSld>
+  <p:clrMap bg1="lt1" bg2="lt2" tx1="dk1" tx2="dk2" accent1="accent1" accent2="accent2" accent3="accent3" accent4="accent4" accent5="accent5" accent6="accent6" hlink="hlink" folHlink="folHlink"/>
+</p:notesMaster>
+</file>
 
 <file path=ppt/notesSlides/notesSlide1.xml><?xml version="1.0" encoding="utf-8"?>
 <p:notes xmlns:a="http://schemas.openxmlformats.org/drawingml/2006/main" xmlns:p="http://schemas.openxmlformats.org/presentationml/2006/main" xmlns:r="http://schemas.openxmlformats.org/officeDocument/2006/relationships" xmlns:p14="http://schemas.microsoft.com/office/powerpoint/2010/main" xmlns:p15="http://schemas.microsoft.com/office/powerpoint/2012/main" xmlns:mc="http://schemas.openxmlformats.org/markup-compatibility/2006">
@@ -13112,4 +13514,279 @@
     </mc:Fallback>
   </mc:AlternateContent>
 </p:sld>
+</file>
+
+<file path=ppt/theme/theme1.xml><?xml version="1.0" encoding="utf-8"?>
+<a:theme xmlns:a="http://schemas.openxmlformats.org/drawingml/2006/main" xmlns:r="http://schemas.openxmlformats.org/officeDocument/2006/relationships" name="Office Theme">
+  <a:themeElements>
+    <a:clrScheme name="Office">
+      <a:dk1>
+        <a:srgbClr val="000000"/>
+      </a:dk1>
+      <a:lt1>
+        <a:srgbClr val="FFFFFF"/>
+      </a:lt1>
+      <a:dk2>
+        <a:srgbClr val="44546A"/>
+      </a:dk2>
+      <a:lt2>
+        <a:srgbClr val="E7E6E6"/>
+      </a:lt2>
+      <a:accent1>
+        <a:srgbClr val="4472C4"/>
+      </a:accent1>
+      <a:accent2>
+        <a:srgbClr val="ED7D31"/>
+      </a:accent2>
+      <a:accent3>
+        <a:srgbClr val="A5A5A5"/>
+      </a:accent3>
+      <a:accent4>
+        <a:srgbClr val="FFC000"/>
+      </a:accent4>
+      <a:accent5>
+        <a:srgbClr val="5B9BD5"/>
+      </a:accent5>
+      <a:accent6>
+        <a:srgbClr val="70AD47"/>
+      </a:accent6>
+      <a:hlink>
+        <a:srgbClr val="0563C1"/>
+      </a:hlink>
+      <a:folHlink>
+        <a:srgbClr val="954F72"/>
+      </a:folHlink>
+    </a:clrScheme>
+    <a:fontScheme name="Office">
+      <a:majorFont>
+        <a:latin typeface="Calibri Light" pitchFamily="0" charset="1"/>
+        <a:ea typeface=""/>
+        <a:cs typeface=""/>
+      </a:majorFont>
+      <a:minorFont>
+        <a:latin typeface="Calibri" pitchFamily="0" charset="1"/>
+        <a:ea typeface=""/>
+        <a:cs typeface=""/>
+      </a:minorFont>
+    </a:fontScheme>
+    <a:fmtScheme>
+      <a:fillStyleLst>
+        <a:solidFill>
+          <a:schemeClr val="phClr"/>
+        </a:solidFill>
+        <a:gradFill>
+          <a:gsLst>
+            <a:gs pos="0">
+              <a:schemeClr val="phClr">
+                <a:tint val="67000"/>
+                <a:lumMod val="110000"/>
+              </a:schemeClr>
+            </a:gs>
+            <a:gs pos="50000">
+              <a:schemeClr val="phClr">
+                <a:tint val="73000"/>
+                <a:lumMod val="105000"/>
+              </a:schemeClr>
+            </a:gs>
+            <a:gs pos="100000">
+              <a:schemeClr val="phClr">
+                <a:tint val="81000"/>
+                <a:lumMod val="105000"/>
+              </a:schemeClr>
+            </a:gs>
+          </a:gsLst>
+          <a:lin ang="5400000" scaled="0"/>
+          <a:tileRect l="0" t="0" r="0" b="0"/>
+        </a:gradFill>
+        <a:gradFill>
+          <a:gsLst>
+            <a:gs pos="0">
+              <a:schemeClr val="phClr">
+                <a:tint val="94000"/>
+                <a:lumMod val="102000"/>
+              </a:schemeClr>
+            </a:gs>
+            <a:gs pos="50000">
+              <a:schemeClr val="phClr">
+                <a:shade val="100000"/>
+                <a:lumMod val="100000"/>
+              </a:schemeClr>
+            </a:gs>
+            <a:gs pos="100000">
+              <a:schemeClr val="phClr">
+                <a:shade val="78000"/>
+                <a:lumMod val="99000"/>
+              </a:schemeClr>
+            </a:gs>
+          </a:gsLst>
+          <a:lin ang="5400000" scaled="0"/>
+          <a:tileRect l="0" t="0" r="0" b="0"/>
+        </a:gradFill>
+      </a:fillStyleLst>
+      <a:lnStyleLst>
+        <a:ln w="6350">
+          <a:prstDash val="solid"/>
+        </a:ln>
+        <a:ln w="12700">
+          <a:prstDash val="solid"/>
+        </a:ln>
+        <a:ln w="19050">
+          <a:prstDash val="solid"/>
+        </a:ln>
+      </a:lnStyleLst>
+      <a:effectStyleLst>
+        <a:effectStyle>
+          <a:effectLst/>
+        </a:effectStyle>
+        <a:effectStyle>
+          <a:effectLst/>
+        </a:effectStyle>
+        <a:effectStyle>
+          <a:effectLst/>
+        </a:effectStyle>
+      </a:effectStyleLst>
+      <a:bgFillStyleLst>
+        <a:solidFill>
+          <a:schemeClr val="phClr"/>
+        </a:solidFill>
+        <a:solidFill>
+          <a:schemeClr val="phClr">
+            <a:tint val="95000"/>
+          </a:schemeClr>
+        </a:solidFill>
+        <a:gradFill>
+          <a:gsLst>
+            <a:gs pos="0">
+              <a:schemeClr val="phClr">
+                <a:tint val="93000"/>
+                <a:shade val="98000"/>
+                <a:lumMod val="102000"/>
+              </a:schemeClr>
+            </a:gs>
+            <a:gs pos="50000">
+              <a:schemeClr val="phClr">
+                <a:tint val="98000"/>
+                <a:shade val="90000"/>
+                <a:lumMod val="103000"/>
+              </a:schemeClr>
+            </a:gs>
+            <a:gs pos="100000">
+              <a:schemeClr val="phClr">
+                <a:shade val="63000"/>
+              </a:schemeClr>
+            </a:gs>
+          </a:gsLst>
+          <a:lin ang="5400000" scaled="0"/>
+          <a:tileRect l="0" t="0" r="0" b="0"/>
+        </a:gradFill>
+      </a:bgFillStyleLst>
+    </a:fmtScheme>
+  </a:themeElements>
+</a:theme>
+</file>
+
+<file path=ppt/theme/theme2.xml><?xml version="1.0" encoding="utf-8"?>
+<a:theme xmlns:a="http://schemas.openxmlformats.org/drawingml/2006/main" xmlns:r="http://schemas.openxmlformats.org/officeDocument/2006/relationships" name="Office Theme">
+  <a:themeElements>
+    <a:clrScheme name="LibreOffice">
+      <a:dk1>
+        <a:srgbClr val="000000"/>
+      </a:dk1>
+      <a:lt1>
+        <a:srgbClr val="FFFFFF"/>
+      </a:lt1>
+      <a:dk2>
+        <a:srgbClr val="000000"/>
+      </a:dk2>
+      <a:lt2>
+        <a:srgbClr val="FFFFFF"/>
+      </a:lt2>
+      <a:accent1>
+        <a:srgbClr val="18A303"/>
+      </a:accent1>
+      <a:accent2>
+        <a:srgbClr val="0369A3"/>
+      </a:accent2>
+      <a:accent3>
+        <a:srgbClr val="A33E03"/>
+      </a:accent3>
+      <a:accent4>
+        <a:srgbClr val="8E03A3"/>
+      </a:accent4>
+      <a:accent5>
+        <a:srgbClr val="C99C00"/>
+      </a:accent5>
+      <a:accent6>
+        <a:srgbClr val="C9211E"/>
+      </a:accent6>
+      <a:hlink>
+        <a:srgbClr val="0000EE"/>
+      </a:hlink>
+      <a:folHlink>
+        <a:srgbClr val="551A8B"/>
+      </a:folHlink>
+    </a:clrScheme>
+    <a:fontScheme name="Office">
+      <a:majorFont>
+        <a:latin typeface="Arial" pitchFamily="0" charset="1"/>
+        <a:ea typeface="DejaVu Sans" pitchFamily="0" charset="1"/>
+        <a:cs typeface="DejaVu Sans" pitchFamily="0" charset="1"/>
+      </a:majorFont>
+      <a:minorFont>
+        <a:latin typeface="Arial" pitchFamily="0" charset="1"/>
+        <a:ea typeface="DejaVu Sans" pitchFamily="0" charset="1"/>
+        <a:cs typeface="DejaVu Sans" pitchFamily="0" charset="1"/>
+      </a:minorFont>
+    </a:fontScheme>
+    <a:fmtScheme>
+      <a:fillStyleLst>
+        <a:solidFill>
+          <a:schemeClr val="phClr"/>
+        </a:solidFill>
+        <a:solidFill>
+          <a:schemeClr val="phClr"/>
+        </a:solidFill>
+        <a:solidFill>
+          <a:schemeClr val="phClr"/>
+        </a:solidFill>
+      </a:fillStyleLst>
+      <a:lnStyleLst>
+        <a:ln w="6350" cap="flat" cmpd="sng" algn="ctr">
+          <a:prstDash val="solid"/>
+          <a:miter/>
+        </a:ln>
+        <a:ln w="6350" cap="flat" cmpd="sng" algn="ctr">
+          <a:prstDash val="solid"/>
+          <a:miter/>
+        </a:ln>
+        <a:ln w="6350" cap="flat" cmpd="sng" algn="ctr">
+          <a:prstDash val="solid"/>
+          <a:miter/>
+        </a:ln>
+      </a:lnStyleLst>
+      <a:effectStyleLst>
+        <a:effectStyle>
+          <a:effectLst/>
+        </a:effectStyle>
+        <a:effectStyle>
+          <a:effectLst/>
+        </a:effectStyle>
+        <a:effectStyle>
+          <a:effectLst/>
+        </a:effectStyle>
+      </a:effectStyleLst>
+      <a:bgFillStyleLst>
+        <a:solidFill>
+          <a:schemeClr val="phClr"/>
+        </a:solidFill>
+        <a:solidFill>
+          <a:schemeClr val="phClr"/>
+        </a:solidFill>
+        <a:solidFill>
+          <a:schemeClr val="phClr"/>
+        </a:solidFill>
+      </a:bgFillStyleLst>
+    </a:fmtScheme>
+  </a:themeElements>
+</a:theme>
 </file>
</xml_diff>